<commit_message>
Updated packages and version. Added camera orientation controls.
</commit_message>
<xml_diff>
--- a/save/title.pptx
+++ b/save/title.pptx
@@ -5,9 +5,8 @@
     <p:sldMasterId id="2147483672" r:id="rId1"/>
   </p:sldMasterIdLst>
   <p:sldIdLst>
-    <p:sldId id="256" r:id="rId2"/>
-    <p:sldId id="258" r:id="rId3"/>
-    <p:sldId id="257" r:id="rId4"/>
+    <p:sldId id="258" r:id="rId2"/>
+    <p:sldId id="259" r:id="rId3"/>
   </p:sldIdLst>
   <p:sldSz cx="12192000" cy="6858000"/>
   <p:notesSz cx="6858000" cy="9144000"/>
@@ -106,6 +105,11 @@
       </a:defRPr>
     </a:lvl9pPr>
   </p:defaultTextStyle>
+  <p:extLst>
+    <p:ext uri="{EFAFB233-063F-42B5-8137-9DF3F51BA10A}">
+      <p15:sldGuideLst xmlns:p15="http://schemas.microsoft.com/office/powerpoint/2012/main"/>
+    </p:ext>
+  </p:extLst>
 </p:presentation>
 </file>
 
@@ -240,7 +244,7 @@
           <a:p>
             <a:fld id="{C3C10EE4-E109-4AA8-B587-926068168109}" type="datetimeFigureOut">
               <a:rPr lang="it-IT" smtClean="0"/>
-              <a:t>05/06/2025</a:t>
+              <a:t>13/06/2025</a:t>
             </a:fld>
             <a:endParaRPr lang="it-IT"/>
           </a:p>
@@ -410,7 +414,7 @@
           <a:p>
             <a:fld id="{C3C10EE4-E109-4AA8-B587-926068168109}" type="datetimeFigureOut">
               <a:rPr lang="it-IT" smtClean="0"/>
-              <a:t>05/06/2025</a:t>
+              <a:t>13/06/2025</a:t>
             </a:fld>
             <a:endParaRPr lang="it-IT"/>
           </a:p>
@@ -590,7 +594,7 @@
           <a:p>
             <a:fld id="{C3C10EE4-E109-4AA8-B587-926068168109}" type="datetimeFigureOut">
               <a:rPr lang="it-IT" smtClean="0"/>
-              <a:t>05/06/2025</a:t>
+              <a:t>13/06/2025</a:t>
             </a:fld>
             <a:endParaRPr lang="it-IT"/>
           </a:p>
@@ -760,7 +764,7 @@
           <a:p>
             <a:fld id="{C3C10EE4-E109-4AA8-B587-926068168109}" type="datetimeFigureOut">
               <a:rPr lang="it-IT" smtClean="0"/>
-              <a:t>05/06/2025</a:t>
+              <a:t>13/06/2025</a:t>
             </a:fld>
             <a:endParaRPr lang="it-IT"/>
           </a:p>
@@ -1006,7 +1010,7 @@
           <a:p>
             <a:fld id="{C3C10EE4-E109-4AA8-B587-926068168109}" type="datetimeFigureOut">
               <a:rPr lang="it-IT" smtClean="0"/>
-              <a:t>05/06/2025</a:t>
+              <a:t>13/06/2025</a:t>
             </a:fld>
             <a:endParaRPr lang="it-IT"/>
           </a:p>
@@ -1238,7 +1242,7 @@
           <a:p>
             <a:fld id="{C3C10EE4-E109-4AA8-B587-926068168109}" type="datetimeFigureOut">
               <a:rPr lang="it-IT" smtClean="0"/>
-              <a:t>05/06/2025</a:t>
+              <a:t>13/06/2025</a:t>
             </a:fld>
             <a:endParaRPr lang="it-IT"/>
           </a:p>
@@ -1605,7 +1609,7 @@
           <a:p>
             <a:fld id="{C3C10EE4-E109-4AA8-B587-926068168109}" type="datetimeFigureOut">
               <a:rPr lang="it-IT" smtClean="0"/>
-              <a:t>05/06/2025</a:t>
+              <a:t>13/06/2025</a:t>
             </a:fld>
             <a:endParaRPr lang="it-IT"/>
           </a:p>
@@ -1723,7 +1727,7 @@
           <a:p>
             <a:fld id="{C3C10EE4-E109-4AA8-B587-926068168109}" type="datetimeFigureOut">
               <a:rPr lang="it-IT" smtClean="0"/>
-              <a:t>05/06/2025</a:t>
+              <a:t>13/06/2025</a:t>
             </a:fld>
             <a:endParaRPr lang="it-IT"/>
           </a:p>
@@ -1818,7 +1822,7 @@
           <a:p>
             <a:fld id="{C3C10EE4-E109-4AA8-B587-926068168109}" type="datetimeFigureOut">
               <a:rPr lang="it-IT" smtClean="0"/>
-              <a:t>05/06/2025</a:t>
+              <a:t>13/06/2025</a:t>
             </a:fld>
             <a:endParaRPr lang="it-IT"/>
           </a:p>
@@ -2095,7 +2099,7 @@
           <a:p>
             <a:fld id="{C3C10EE4-E109-4AA8-B587-926068168109}" type="datetimeFigureOut">
               <a:rPr lang="it-IT" smtClean="0"/>
-              <a:t>05/06/2025</a:t>
+              <a:t>13/06/2025</a:t>
             </a:fld>
             <a:endParaRPr lang="it-IT"/>
           </a:p>
@@ -2352,7 +2356,7 @@
           <a:p>
             <a:fld id="{C3C10EE4-E109-4AA8-B587-926068168109}" type="datetimeFigureOut">
               <a:rPr lang="it-IT" smtClean="0"/>
-              <a:t>05/06/2025</a:t>
+              <a:t>13/06/2025</a:t>
             </a:fld>
             <a:endParaRPr lang="it-IT"/>
           </a:p>
@@ -2565,7 +2569,7 @@
           <a:p>
             <a:fld id="{C3C10EE4-E109-4AA8-B587-926068168109}" type="datetimeFigureOut">
               <a:rPr lang="it-IT" smtClean="0"/>
-              <a:t>05/06/2025</a:t>
+              <a:t>13/06/2025</a:t>
             </a:fld>
             <a:endParaRPr lang="it-IT"/>
           </a:p>
@@ -2970,92 +2974,12 @@
           <a:chExt cx="0" cy="0"/>
         </a:xfrm>
       </p:grpSpPr>
-      <p:sp>
-        <p:nvSpPr>
-          <p:cNvPr id="2" name="Title 1">
+      <p:pic>
+        <p:nvPicPr>
+          <p:cNvPr id="7" name="Picture 6">
             <a:extLst>
               <a:ext uri="{FF2B5EF4-FFF2-40B4-BE49-F238E27FC236}">
-                <a16:creationId xmlns:a16="http://schemas.microsoft.com/office/drawing/2014/main" id="{26D6BAAA-EC06-891D-93EB-36F56FF7C0F8}"/>
-              </a:ext>
-            </a:extLst>
-          </p:cNvPr>
-          <p:cNvSpPr>
-            <a:spLocks noGrp="1"/>
-          </p:cNvSpPr>
-          <p:nvPr>
-            <p:ph type="ctrTitle"/>
-          </p:nvPr>
-        </p:nvSpPr>
-        <p:spPr/>
-        <p:txBody>
-          <a:bodyPr/>
-          <a:lstStyle/>
-          <a:p>
-            <a:endParaRPr lang="it-IT"/>
-          </a:p>
-        </p:txBody>
-      </p:sp>
-      <p:sp>
-        <p:nvSpPr>
-          <p:cNvPr id="3" name="Subtitle 2">
-            <a:extLst>
-              <a:ext uri="{FF2B5EF4-FFF2-40B4-BE49-F238E27FC236}">
-                <a16:creationId xmlns:a16="http://schemas.microsoft.com/office/drawing/2014/main" id="{3171562B-DBA3-39E8-E50D-681217D2DB44}"/>
-              </a:ext>
-            </a:extLst>
-          </p:cNvPr>
-          <p:cNvSpPr>
-            <a:spLocks noGrp="1"/>
-          </p:cNvSpPr>
-          <p:nvPr>
-            <p:ph type="subTitle" idx="1"/>
-          </p:nvPr>
-        </p:nvSpPr>
-        <p:spPr/>
-        <p:txBody>
-          <a:bodyPr/>
-          <a:lstStyle/>
-          <a:p>
-            <a:endParaRPr lang="it-IT"/>
-          </a:p>
-        </p:txBody>
-      </p:sp>
-    </p:spTree>
-    <p:extLst>
-      <p:ext uri="{BB962C8B-B14F-4D97-AF65-F5344CB8AC3E}">
-        <p14:creationId xmlns:p14="http://schemas.microsoft.com/office/powerpoint/2010/main" val="979472791"/>
-      </p:ext>
-    </p:extLst>
-  </p:cSld>
-  <p:clrMapOvr>
-    <a:masterClrMapping/>
-  </p:clrMapOvr>
-</p:sld>
-</file>
-
-<file path=ppt/slides/slide2.xml><?xml version="1.0" encoding="utf-8"?>
-<p:sld xmlns:a="http://schemas.openxmlformats.org/drawingml/2006/main" xmlns:r="http://schemas.openxmlformats.org/officeDocument/2006/relationships" xmlns:p="http://schemas.openxmlformats.org/presentationml/2006/main">
-  <p:cSld>
-    <p:spTree>
-      <p:nvGrpSpPr>
-        <p:cNvPr id="1" name=""/>
-        <p:cNvGrpSpPr/>
-        <p:nvPr/>
-      </p:nvGrpSpPr>
-      <p:grpSpPr>
-        <a:xfrm>
-          <a:off x="0" y="0"/>
-          <a:ext cx="0" cy="0"/>
-          <a:chOff x="0" y="0"/>
-          <a:chExt cx="0" cy="0"/>
-        </a:xfrm>
-      </p:grpSpPr>
-      <p:pic>
-        <p:nvPicPr>
-          <p:cNvPr id="5" name="Picture 4" descr="A computer screen shot of a molecule&#10;&#10;AI-generated content may be incorrect.">
-            <a:extLst>
-              <a:ext uri="{FF2B5EF4-FFF2-40B4-BE49-F238E27FC236}">
-                <a16:creationId xmlns:a16="http://schemas.microsoft.com/office/drawing/2014/main" id="{FDA570D8-64B2-B7E8-2754-B4AB182E284A}"/>
+                <a16:creationId xmlns:a16="http://schemas.microsoft.com/office/drawing/2014/main" id="{583C793A-8572-3792-3A59-012C905A231F}"/>
               </a:ext>
             </a:extLst>
           </p:cNvPr>
@@ -3065,21 +2989,15 @@
           <p:nvPr/>
         </p:nvPicPr>
         <p:blipFill>
-          <a:blip r:embed="rId2">
-            <a:extLst>
-              <a:ext uri="{28A0092B-C50C-407E-A947-70E740481C1C}">
-                <a14:useLocalDpi xmlns:a14="http://schemas.microsoft.com/office/drawing/2010/main" val="0"/>
-              </a:ext>
-            </a:extLst>
-          </a:blip>
+          <a:blip r:embed="rId2"/>
           <a:stretch>
             <a:fillRect/>
           </a:stretch>
         </p:blipFill>
         <p:spPr>
           <a:xfrm>
-            <a:off x="-1" y="0"/>
-            <a:ext cx="12192001" cy="6858000"/>
+            <a:off x="0" y="0"/>
+            <a:ext cx="12192000" cy="6858000"/>
           </a:xfrm>
           <a:prstGeom prst="rect">
             <a:avLst/>
@@ -3100,7 +3018,7 @@
         </p:nvSpPr>
         <p:spPr>
           <a:xfrm>
-            <a:off x="8325853" y="5292757"/>
+            <a:off x="8325853" y="5148921"/>
             <a:ext cx="3648078" cy="1455174"/>
           </a:xfrm>
           <a:prstGeom prst="roundRect">
@@ -3170,9 +3088,17 @@
 </p:sld>
 </file>
 
-<file path=ppt/slides/slide3.xml><?xml version="1.0" encoding="utf-8"?>
+<file path=ppt/slides/slide2.xml><?xml version="1.0" encoding="utf-8"?>
 <p:sld xmlns:a="http://schemas.openxmlformats.org/drawingml/2006/main" xmlns:r="http://schemas.openxmlformats.org/officeDocument/2006/relationships" xmlns:p="http://schemas.openxmlformats.org/presentationml/2006/main">
   <p:cSld>
+    <p:bg>
+      <p:bgPr>
+        <a:solidFill>
+          <a:schemeClr val="bg1"/>
+        </a:solidFill>
+        <a:effectLst/>
+      </p:bgPr>
+    </p:bg>
     <p:spTree>
       <p:nvGrpSpPr>
         <p:cNvPr id="1" name=""/>
@@ -3187,12 +3113,167 @@
           <a:chExt cx="0" cy="0"/>
         </a:xfrm>
       </p:grpSpPr>
+      <p:sp>
+        <p:nvSpPr>
+          <p:cNvPr id="10" name="Rectangle 9">
+            <a:extLst>
+              <a:ext uri="{FF2B5EF4-FFF2-40B4-BE49-F238E27FC236}">
+                <a16:creationId xmlns:a16="http://schemas.microsoft.com/office/drawing/2014/main" id="{42A4FC2C-047E-45A5-965D-8E1E3BF09BC6}"/>
+              </a:ext>
+              <a:ext uri="{C183D7F6-B498-43B3-948B-1728B52AA6E4}">
+                <adec:decorative xmlns:adec="http://schemas.microsoft.com/office/drawing/2017/decorative" val="1"/>
+              </a:ext>
+            </a:extLst>
+          </p:cNvPr>
+          <p:cNvSpPr>
+            <a:spLocks noGrp="1" noRot="1" noChangeAspect="1" noMove="1" noResize="1" noEditPoints="1" noAdjustHandles="1" noChangeArrowheads="1" noChangeShapeType="1" noTextEdit="1"/>
+          </p:cNvSpPr>
+          <p:nvPr>
+            <p:extLst>
+              <p:ext uri="{386F3935-93C4-4BCD-93E2-E3B085C9AB24}">
+                <p16:designElem xmlns:p16="http://schemas.microsoft.com/office/powerpoint/2015/main" val="1"/>
+              </p:ext>
+            </p:extLst>
+          </p:nvPr>
+        </p:nvSpPr>
+        <p:spPr bwMode="white">
+          <a:xfrm>
+            <a:off x="1524" y="0"/>
+            <a:ext cx="12188952" cy="6858000"/>
+          </a:xfrm>
+          <a:prstGeom prst="rect">
+            <a:avLst/>
+          </a:prstGeom>
+          <a:noFill/>
+          <a:ln>
+            <a:noFill/>
+          </a:ln>
+        </p:spPr>
+        <p:style>
+          <a:lnRef idx="2">
+            <a:schemeClr val="accent1">
+              <a:shade val="50000"/>
+            </a:schemeClr>
+          </a:lnRef>
+          <a:fillRef idx="1">
+            <a:schemeClr val="accent1"/>
+          </a:fillRef>
+          <a:effectRef idx="0">
+            <a:schemeClr val="accent1"/>
+          </a:effectRef>
+          <a:fontRef idx="minor">
+            <a:schemeClr val="lt1"/>
+          </a:fontRef>
+        </p:style>
+        <p:txBody>
+          <a:bodyPr rtlCol="0" anchor="ctr"/>
+          <a:lstStyle>
+            <a:defPPr>
+              <a:defRPr lang="en-US"/>
+            </a:defPPr>
+            <a:lvl1pPr marL="0" algn="l" defTabSz="914400" rtl="0" eaLnBrk="1" latinLnBrk="0" hangingPunct="1">
+              <a:defRPr sz="1800" kern="1200">
+                <a:solidFill>
+                  <a:schemeClr val="lt1"/>
+                </a:solidFill>
+                <a:latin typeface="+mn-lt"/>
+                <a:ea typeface="+mn-ea"/>
+                <a:cs typeface="+mn-cs"/>
+              </a:defRPr>
+            </a:lvl1pPr>
+            <a:lvl2pPr marL="457200" algn="l" defTabSz="914400" rtl="0" eaLnBrk="1" latinLnBrk="0" hangingPunct="1">
+              <a:defRPr sz="1800" kern="1200">
+                <a:solidFill>
+                  <a:schemeClr val="lt1"/>
+                </a:solidFill>
+                <a:latin typeface="+mn-lt"/>
+                <a:ea typeface="+mn-ea"/>
+                <a:cs typeface="+mn-cs"/>
+              </a:defRPr>
+            </a:lvl2pPr>
+            <a:lvl3pPr marL="914400" algn="l" defTabSz="914400" rtl="0" eaLnBrk="1" latinLnBrk="0" hangingPunct="1">
+              <a:defRPr sz="1800" kern="1200">
+                <a:solidFill>
+                  <a:schemeClr val="lt1"/>
+                </a:solidFill>
+                <a:latin typeface="+mn-lt"/>
+                <a:ea typeface="+mn-ea"/>
+                <a:cs typeface="+mn-cs"/>
+              </a:defRPr>
+            </a:lvl3pPr>
+            <a:lvl4pPr marL="1371600" algn="l" defTabSz="914400" rtl="0" eaLnBrk="1" latinLnBrk="0" hangingPunct="1">
+              <a:defRPr sz="1800" kern="1200">
+                <a:solidFill>
+                  <a:schemeClr val="lt1"/>
+                </a:solidFill>
+                <a:latin typeface="+mn-lt"/>
+                <a:ea typeface="+mn-ea"/>
+                <a:cs typeface="+mn-cs"/>
+              </a:defRPr>
+            </a:lvl4pPr>
+            <a:lvl5pPr marL="1828800" algn="l" defTabSz="914400" rtl="0" eaLnBrk="1" latinLnBrk="0" hangingPunct="1">
+              <a:defRPr sz="1800" kern="1200">
+                <a:solidFill>
+                  <a:schemeClr val="lt1"/>
+                </a:solidFill>
+                <a:latin typeface="+mn-lt"/>
+                <a:ea typeface="+mn-ea"/>
+                <a:cs typeface="+mn-cs"/>
+              </a:defRPr>
+            </a:lvl5pPr>
+            <a:lvl6pPr marL="2286000" algn="l" defTabSz="914400" rtl="0" eaLnBrk="1" latinLnBrk="0" hangingPunct="1">
+              <a:defRPr sz="1800" kern="1200">
+                <a:solidFill>
+                  <a:schemeClr val="lt1"/>
+                </a:solidFill>
+                <a:latin typeface="+mn-lt"/>
+                <a:ea typeface="+mn-ea"/>
+                <a:cs typeface="+mn-cs"/>
+              </a:defRPr>
+            </a:lvl6pPr>
+            <a:lvl7pPr marL="2743200" algn="l" defTabSz="914400" rtl="0" eaLnBrk="1" latinLnBrk="0" hangingPunct="1">
+              <a:defRPr sz="1800" kern="1200">
+                <a:solidFill>
+                  <a:schemeClr val="lt1"/>
+                </a:solidFill>
+                <a:latin typeface="+mn-lt"/>
+                <a:ea typeface="+mn-ea"/>
+                <a:cs typeface="+mn-cs"/>
+              </a:defRPr>
+            </a:lvl7pPr>
+            <a:lvl8pPr marL="3200400" algn="l" defTabSz="914400" rtl="0" eaLnBrk="1" latinLnBrk="0" hangingPunct="1">
+              <a:defRPr sz="1800" kern="1200">
+                <a:solidFill>
+                  <a:schemeClr val="lt1"/>
+                </a:solidFill>
+                <a:latin typeface="+mn-lt"/>
+                <a:ea typeface="+mn-ea"/>
+                <a:cs typeface="+mn-cs"/>
+              </a:defRPr>
+            </a:lvl8pPr>
+            <a:lvl9pPr marL="3657600" algn="l" defTabSz="914400" rtl="0" eaLnBrk="1" latinLnBrk="0" hangingPunct="1">
+              <a:defRPr sz="1800" kern="1200">
+                <a:solidFill>
+                  <a:schemeClr val="lt1"/>
+                </a:solidFill>
+                <a:latin typeface="+mn-lt"/>
+                <a:ea typeface="+mn-ea"/>
+                <a:cs typeface="+mn-cs"/>
+              </a:defRPr>
+            </a:lvl9pPr>
+          </a:lstStyle>
+          <a:p>
+            <a:pPr algn="ctr"/>
+            <a:endParaRPr lang="en-US"/>
+          </a:p>
+        </p:txBody>
+      </p:sp>
       <p:pic>
         <p:nvPicPr>
-          <p:cNvPr id="3" name="Picture 2" descr="A computer screen shot of a molecule&#10;&#10;AI-generated content may be incorrect.">
+          <p:cNvPr id="5" name="Picture 4" descr="A computer screen shot of a computer">
             <a:extLst>
               <a:ext uri="{FF2B5EF4-FFF2-40B4-BE49-F238E27FC236}">
-                <a16:creationId xmlns:a16="http://schemas.microsoft.com/office/drawing/2014/main" id="{54F441CE-AF88-B78E-60C2-7777EDB1007A}"/>
+                <a16:creationId xmlns:a16="http://schemas.microsoft.com/office/drawing/2014/main" id="{7144C5B5-9393-575E-B726-FD4C68C05729}"/>
               </a:ext>
             </a:extLst>
           </p:cNvPr>
@@ -3209,24 +3290,591 @@
               </a:ext>
             </a:extLst>
           </a:blip>
+          <a:srcRect l="1" t="1" r="1" b="1"/>
           <a:stretch>
             <a:fillRect/>
           </a:stretch>
         </p:blipFill>
         <p:spPr>
           <a:xfrm>
-            <a:off x="1524000" y="971550"/>
-            <a:ext cx="9144000" cy="4914900"/>
+            <a:off x="20" y="1282"/>
+            <a:ext cx="12191980" cy="6856718"/>
           </a:xfrm>
           <a:prstGeom prst="rect">
             <a:avLst/>
           </a:prstGeom>
         </p:spPr>
       </p:pic>
+      <p:sp>
+        <p:nvSpPr>
+          <p:cNvPr id="6" name="TextBox 5">
+            <a:extLst>
+              <a:ext uri="{FF2B5EF4-FFF2-40B4-BE49-F238E27FC236}">
+                <a16:creationId xmlns:a16="http://schemas.microsoft.com/office/drawing/2014/main" id="{A268CC9A-697D-4943-BCC3-5C81036620D2}"/>
+              </a:ext>
+            </a:extLst>
+          </p:cNvPr>
+          <p:cNvSpPr txBox="1"/>
+          <p:nvPr/>
+        </p:nvSpPr>
+        <p:spPr>
+          <a:xfrm>
+            <a:off x="3298005" y="380144"/>
+            <a:ext cx="2680157" cy="584775"/>
+          </a:xfrm>
+          <a:prstGeom prst="rect">
+            <a:avLst/>
+          </a:prstGeom>
+          <a:noFill/>
+        </p:spPr>
+        <p:txBody>
+          <a:bodyPr wrap="none" rtlCol="0">
+            <a:spAutoFit/>
+          </a:bodyPr>
+          <a:lstStyle/>
+          <a:p>
+            <a:r>
+              <a:rPr lang="en-US" sz="3200" dirty="0">
+                <a:solidFill>
+                  <a:srgbClr val="FF0000"/>
+                </a:solidFill>
+              </a:rPr>
+              <a:t>Node selector</a:t>
+            </a:r>
+          </a:p>
+        </p:txBody>
+      </p:sp>
+      <p:cxnSp>
+        <p:nvCxnSpPr>
+          <p:cNvPr id="8" name="Straight Arrow Connector 7">
+            <a:extLst>
+              <a:ext uri="{FF2B5EF4-FFF2-40B4-BE49-F238E27FC236}">
+                <a16:creationId xmlns:a16="http://schemas.microsoft.com/office/drawing/2014/main" id="{8325ECBF-18C8-FAFB-FF94-0C902A4A04C9}"/>
+              </a:ext>
+            </a:extLst>
+          </p:cNvPr>
+          <p:cNvCxnSpPr>
+            <a:cxnSpLocks/>
+            <a:stCxn id="6" idx="1"/>
+          </p:cNvCxnSpPr>
+          <p:nvPr/>
+        </p:nvCxnSpPr>
+        <p:spPr>
+          <a:xfrm flipH="1" flipV="1">
+            <a:off x="2024009" y="422184"/>
+            <a:ext cx="1273996" cy="250348"/>
+          </a:xfrm>
+          <a:prstGeom prst="straightConnector1">
+            <a:avLst/>
+          </a:prstGeom>
+          <a:ln w="38100">
+            <a:solidFill>
+              <a:srgbClr val="FF0000"/>
+            </a:solidFill>
+            <a:tailEnd type="triangle" w="lg" len="lg"/>
+          </a:ln>
+          <a:effectLst/>
+        </p:spPr>
+        <p:style>
+          <a:lnRef idx="2">
+            <a:schemeClr val="accent1"/>
+          </a:lnRef>
+          <a:fillRef idx="0">
+            <a:schemeClr val="accent1"/>
+          </a:fillRef>
+          <a:effectRef idx="1">
+            <a:schemeClr val="accent1"/>
+          </a:effectRef>
+          <a:fontRef idx="minor">
+            <a:schemeClr val="tx1"/>
+          </a:fontRef>
+        </p:style>
+      </p:cxnSp>
+      <p:sp>
+        <p:nvSpPr>
+          <p:cNvPr id="9" name="TextBox 8">
+            <a:extLst>
+              <a:ext uri="{FF2B5EF4-FFF2-40B4-BE49-F238E27FC236}">
+                <a16:creationId xmlns:a16="http://schemas.microsoft.com/office/drawing/2014/main" id="{73C8754D-462F-060F-0AD5-B96D86FDE0F6}"/>
+              </a:ext>
+            </a:extLst>
+          </p:cNvPr>
+          <p:cNvSpPr txBox="1"/>
+          <p:nvPr/>
+        </p:nvSpPr>
+        <p:spPr>
+          <a:xfrm>
+            <a:off x="3390473" y="5287058"/>
+            <a:ext cx="1620957" cy="1569660"/>
+          </a:xfrm>
+          <a:prstGeom prst="rect">
+            <a:avLst/>
+          </a:prstGeom>
+          <a:noFill/>
+        </p:spPr>
+        <p:txBody>
+          <a:bodyPr wrap="none" rtlCol="0">
+            <a:spAutoFit/>
+          </a:bodyPr>
+          <a:lstStyle/>
+          <a:p>
+            <a:r>
+              <a:rPr lang="en-US" sz="3200" dirty="0">
+                <a:solidFill>
+                  <a:srgbClr val="FF0000"/>
+                </a:solidFill>
+              </a:rPr>
+              <a:t>Manage</a:t>
+            </a:r>
+            <a:br>
+              <a:rPr lang="en-US" sz="3200" dirty="0">
+                <a:solidFill>
+                  <a:srgbClr val="FF0000"/>
+                </a:solidFill>
+              </a:rPr>
+            </a:br>
+            <a:r>
+              <a:rPr lang="en-US" sz="3200" dirty="0">
+                <a:solidFill>
+                  <a:srgbClr val="FF0000"/>
+                </a:solidFill>
+              </a:rPr>
+              <a:t>camera</a:t>
+            </a:r>
+            <a:br>
+              <a:rPr lang="en-US" sz="3200" dirty="0">
+                <a:solidFill>
+                  <a:srgbClr val="FF0000"/>
+                </a:solidFill>
+              </a:rPr>
+            </a:br>
+            <a:r>
+              <a:rPr lang="en-US" sz="3200" dirty="0">
+                <a:solidFill>
+                  <a:srgbClr val="FF0000"/>
+                </a:solidFill>
+              </a:rPr>
+              <a:t>position</a:t>
+            </a:r>
+          </a:p>
+        </p:txBody>
+      </p:sp>
+      <p:cxnSp>
+        <p:nvCxnSpPr>
+          <p:cNvPr id="11" name="Straight Arrow Connector 10">
+            <a:extLst>
+              <a:ext uri="{FF2B5EF4-FFF2-40B4-BE49-F238E27FC236}">
+                <a16:creationId xmlns:a16="http://schemas.microsoft.com/office/drawing/2014/main" id="{193BD93F-7ECD-F17D-D841-911A36912A66}"/>
+              </a:ext>
+            </a:extLst>
+          </p:cNvPr>
+          <p:cNvCxnSpPr>
+            <a:cxnSpLocks/>
+            <a:stCxn id="9" idx="1"/>
+          </p:cNvCxnSpPr>
+          <p:nvPr/>
+        </p:nvCxnSpPr>
+        <p:spPr>
+          <a:xfrm flipH="1">
+            <a:off x="1808252" y="6071888"/>
+            <a:ext cx="1582221" cy="641633"/>
+          </a:xfrm>
+          <a:prstGeom prst="straightConnector1">
+            <a:avLst/>
+          </a:prstGeom>
+          <a:ln w="38100">
+            <a:solidFill>
+              <a:srgbClr val="FF0000"/>
+            </a:solidFill>
+            <a:tailEnd type="triangle" w="lg" len="lg"/>
+          </a:ln>
+          <a:effectLst/>
+        </p:spPr>
+        <p:style>
+          <a:lnRef idx="2">
+            <a:schemeClr val="accent1"/>
+          </a:lnRef>
+          <a:fillRef idx="0">
+            <a:schemeClr val="accent1"/>
+          </a:fillRef>
+          <a:effectRef idx="1">
+            <a:schemeClr val="accent1"/>
+          </a:effectRef>
+          <a:fontRef idx="minor">
+            <a:schemeClr val="tx1"/>
+          </a:fontRef>
+        </p:style>
+      </p:cxnSp>
+      <p:sp>
+        <p:nvSpPr>
+          <p:cNvPr id="14" name="TextBox 13">
+            <a:extLst>
+              <a:ext uri="{FF2B5EF4-FFF2-40B4-BE49-F238E27FC236}">
+                <a16:creationId xmlns:a16="http://schemas.microsoft.com/office/drawing/2014/main" id="{F1F89045-265B-F855-F354-EF0C25CF827A}"/>
+              </a:ext>
+            </a:extLst>
+          </p:cNvPr>
+          <p:cNvSpPr txBox="1"/>
+          <p:nvPr/>
+        </p:nvSpPr>
+        <p:spPr>
+          <a:xfrm>
+            <a:off x="3390473" y="4393703"/>
+            <a:ext cx="1322413" cy="584775"/>
+          </a:xfrm>
+          <a:prstGeom prst="rect">
+            <a:avLst/>
+          </a:prstGeom>
+          <a:noFill/>
+        </p:spPr>
+        <p:txBody>
+          <a:bodyPr wrap="none" rtlCol="0">
+            <a:spAutoFit/>
+          </a:bodyPr>
+          <a:lstStyle/>
+          <a:p>
+            <a:r>
+              <a:rPr lang="en-US" sz="3200" dirty="0">
+                <a:solidFill>
+                  <a:srgbClr val="FF0000"/>
+                </a:solidFill>
+              </a:rPr>
+              <a:t>Gutter</a:t>
+            </a:r>
+          </a:p>
+        </p:txBody>
+      </p:sp>
+      <p:cxnSp>
+        <p:nvCxnSpPr>
+          <p:cNvPr id="15" name="Straight Arrow Connector 14">
+            <a:extLst>
+              <a:ext uri="{FF2B5EF4-FFF2-40B4-BE49-F238E27FC236}">
+                <a16:creationId xmlns:a16="http://schemas.microsoft.com/office/drawing/2014/main" id="{1E96B905-9F52-17B9-E0E6-8522990D327F}"/>
+              </a:ext>
+            </a:extLst>
+          </p:cNvPr>
+          <p:cNvCxnSpPr>
+            <a:cxnSpLocks/>
+            <a:stCxn id="14" idx="1"/>
+          </p:cNvCxnSpPr>
+          <p:nvPr/>
+        </p:nvCxnSpPr>
+        <p:spPr>
+          <a:xfrm flipH="1">
+            <a:off x="2666144" y="4686091"/>
+            <a:ext cx="724329" cy="4711"/>
+          </a:xfrm>
+          <a:prstGeom prst="straightConnector1">
+            <a:avLst/>
+          </a:prstGeom>
+          <a:ln w="38100">
+            <a:solidFill>
+              <a:srgbClr val="FF0000"/>
+            </a:solidFill>
+            <a:tailEnd type="triangle" w="lg" len="lg"/>
+          </a:ln>
+          <a:effectLst/>
+        </p:spPr>
+        <p:style>
+          <a:lnRef idx="2">
+            <a:schemeClr val="accent1"/>
+          </a:lnRef>
+          <a:fillRef idx="0">
+            <a:schemeClr val="accent1"/>
+          </a:fillRef>
+          <a:effectRef idx="1">
+            <a:schemeClr val="accent1"/>
+          </a:effectRef>
+          <a:fontRef idx="minor">
+            <a:schemeClr val="tx1"/>
+          </a:fontRef>
+        </p:style>
+      </p:cxnSp>
+      <p:sp>
+        <p:nvSpPr>
+          <p:cNvPr id="18" name="TextBox 17">
+            <a:extLst>
+              <a:ext uri="{FF2B5EF4-FFF2-40B4-BE49-F238E27FC236}">
+                <a16:creationId xmlns:a16="http://schemas.microsoft.com/office/drawing/2014/main" id="{42AF29EC-F7FE-4CEB-C2EA-18BC9EE1E91F}"/>
+              </a:ext>
+            </a:extLst>
+          </p:cNvPr>
+          <p:cNvSpPr txBox="1"/>
+          <p:nvPr/>
+        </p:nvSpPr>
+        <p:spPr>
+          <a:xfrm>
+            <a:off x="3197203" y="1748287"/>
+            <a:ext cx="2525820" cy="1077218"/>
+          </a:xfrm>
+          <a:prstGeom prst="rect">
+            <a:avLst/>
+          </a:prstGeom>
+          <a:noFill/>
+        </p:spPr>
+        <p:txBody>
+          <a:bodyPr wrap="none" rtlCol="0">
+            <a:spAutoFit/>
+          </a:bodyPr>
+          <a:lstStyle/>
+          <a:p>
+            <a:r>
+              <a:rPr lang="en-US" sz="3200" dirty="0">
+                <a:solidFill>
+                  <a:srgbClr val="FF0000"/>
+                </a:solidFill>
+              </a:rPr>
+              <a:t>Current node</a:t>
+            </a:r>
+            <a:br>
+              <a:rPr lang="en-US" sz="3200" dirty="0">
+                <a:solidFill>
+                  <a:srgbClr val="FF0000"/>
+                </a:solidFill>
+              </a:rPr>
+            </a:br>
+            <a:r>
+              <a:rPr lang="en-US" sz="3200" dirty="0">
+                <a:solidFill>
+                  <a:srgbClr val="FF0000"/>
+                </a:solidFill>
+              </a:rPr>
+              <a:t>parameters</a:t>
+            </a:r>
+          </a:p>
+        </p:txBody>
+      </p:sp>
+      <p:sp>
+        <p:nvSpPr>
+          <p:cNvPr id="19" name="TextBox 18">
+            <a:extLst>
+              <a:ext uri="{FF2B5EF4-FFF2-40B4-BE49-F238E27FC236}">
+                <a16:creationId xmlns:a16="http://schemas.microsoft.com/office/drawing/2014/main" id="{9C9D18A4-AE08-55D7-011E-E2C7D0C33C43}"/>
+              </a:ext>
+            </a:extLst>
+          </p:cNvPr>
+          <p:cNvSpPr txBox="1"/>
+          <p:nvPr/>
+        </p:nvSpPr>
+        <p:spPr>
+          <a:xfrm>
+            <a:off x="6584211" y="446258"/>
+            <a:ext cx="2877647" cy="584775"/>
+          </a:xfrm>
+          <a:prstGeom prst="rect">
+            <a:avLst/>
+          </a:prstGeom>
+          <a:noFill/>
+        </p:spPr>
+        <p:txBody>
+          <a:bodyPr wrap="none" rtlCol="0">
+            <a:spAutoFit/>
+          </a:bodyPr>
+          <a:lstStyle/>
+          <a:p>
+            <a:r>
+              <a:rPr lang="en-US" sz="3200" dirty="0">
+                <a:solidFill>
+                  <a:srgbClr val="FF0000"/>
+                </a:solidFill>
+              </a:rPr>
+              <a:t>Current project</a:t>
+            </a:r>
+          </a:p>
+        </p:txBody>
+      </p:sp>
+      <p:cxnSp>
+        <p:nvCxnSpPr>
+          <p:cNvPr id="20" name="Straight Arrow Connector 19">
+            <a:extLst>
+              <a:ext uri="{FF2B5EF4-FFF2-40B4-BE49-F238E27FC236}">
+                <a16:creationId xmlns:a16="http://schemas.microsoft.com/office/drawing/2014/main" id="{A99EC29C-53F2-8706-699C-0593174EC458}"/>
+              </a:ext>
+            </a:extLst>
+          </p:cNvPr>
+          <p:cNvCxnSpPr>
+            <a:cxnSpLocks/>
+          </p:cNvCxnSpPr>
+          <p:nvPr/>
+        </p:nvCxnSpPr>
+        <p:spPr>
+          <a:xfrm flipH="1" flipV="1">
+            <a:off x="7027524" y="102741"/>
+            <a:ext cx="371759" cy="444617"/>
+          </a:xfrm>
+          <a:prstGeom prst="straightConnector1">
+            <a:avLst/>
+          </a:prstGeom>
+          <a:ln w="38100">
+            <a:solidFill>
+              <a:srgbClr val="FF0000"/>
+            </a:solidFill>
+            <a:tailEnd type="triangle" w="lg" len="lg"/>
+          </a:ln>
+          <a:effectLst/>
+        </p:spPr>
+        <p:style>
+          <a:lnRef idx="2">
+            <a:schemeClr val="accent1"/>
+          </a:lnRef>
+          <a:fillRef idx="0">
+            <a:schemeClr val="accent1"/>
+          </a:fillRef>
+          <a:effectRef idx="1">
+            <a:schemeClr val="accent1"/>
+          </a:effectRef>
+          <a:fontRef idx="minor">
+            <a:schemeClr val="tx1"/>
+          </a:fontRef>
+        </p:style>
+      </p:cxnSp>
+      <p:sp>
+        <p:nvSpPr>
+          <p:cNvPr id="24" name="TextBox 23">
+            <a:extLst>
+              <a:ext uri="{FF2B5EF4-FFF2-40B4-BE49-F238E27FC236}">
+                <a16:creationId xmlns:a16="http://schemas.microsoft.com/office/drawing/2014/main" id="{0FC2BF58-AA65-3383-9245-46365AE45D60}"/>
+              </a:ext>
+            </a:extLst>
+          </p:cNvPr>
+          <p:cNvSpPr txBox="1"/>
+          <p:nvPr/>
+        </p:nvSpPr>
+        <p:spPr>
+          <a:xfrm>
+            <a:off x="10067907" y="953791"/>
+            <a:ext cx="1970796" cy="584775"/>
+          </a:xfrm>
+          <a:prstGeom prst="rect">
+            <a:avLst/>
+          </a:prstGeom>
+          <a:noFill/>
+        </p:spPr>
+        <p:txBody>
+          <a:bodyPr wrap="none" rtlCol="0">
+            <a:spAutoFit/>
+          </a:bodyPr>
+          <a:lstStyle/>
+          <a:p>
+            <a:r>
+              <a:rPr lang="en-US" sz="3200" dirty="0">
+                <a:solidFill>
+                  <a:srgbClr val="FF0000"/>
+                </a:solidFill>
+              </a:rPr>
+              <a:t>3D Viewer</a:t>
+            </a:r>
+          </a:p>
+        </p:txBody>
+      </p:sp>
+      <p:sp>
+        <p:nvSpPr>
+          <p:cNvPr id="25" name="TextBox 24">
+            <a:extLst>
+              <a:ext uri="{FF2B5EF4-FFF2-40B4-BE49-F238E27FC236}">
+                <a16:creationId xmlns:a16="http://schemas.microsoft.com/office/drawing/2014/main" id="{9B1A4EC3-28D7-D633-D1F8-341585A3927D}"/>
+              </a:ext>
+            </a:extLst>
+          </p:cNvPr>
+          <p:cNvSpPr txBox="1"/>
+          <p:nvPr/>
+        </p:nvSpPr>
+        <p:spPr>
+          <a:xfrm>
+            <a:off x="7493985" y="5406001"/>
+            <a:ext cx="2370970" cy="1077218"/>
+          </a:xfrm>
+          <a:prstGeom prst="rect">
+            <a:avLst/>
+          </a:prstGeom>
+          <a:solidFill>
+            <a:srgbClr val="121212">
+              <a:alpha val="50000"/>
+            </a:srgbClr>
+          </a:solidFill>
+        </p:spPr>
+        <p:txBody>
+          <a:bodyPr wrap="none" rtlCol="0">
+            <a:spAutoFit/>
+          </a:bodyPr>
+          <a:lstStyle/>
+          <a:p>
+            <a:r>
+              <a:rPr lang="en-US" sz="3200" dirty="0">
+                <a:solidFill>
+                  <a:srgbClr val="FF0000"/>
+                </a:solidFill>
+              </a:rPr>
+              <a:t>A secondary</a:t>
+            </a:r>
+            <a:br>
+              <a:rPr lang="en-US" sz="3200" dirty="0">
+                <a:solidFill>
+                  <a:srgbClr val="FF0000"/>
+                </a:solidFill>
+              </a:rPr>
+            </a:br>
+            <a:r>
+              <a:rPr lang="en-US" sz="3200" dirty="0">
+                <a:solidFill>
+                  <a:srgbClr val="FF0000"/>
+                </a:solidFill>
+              </a:rPr>
+              <a:t>window</a:t>
+            </a:r>
+          </a:p>
+        </p:txBody>
+      </p:sp>
+      <p:cxnSp>
+        <p:nvCxnSpPr>
+          <p:cNvPr id="26" name="Straight Arrow Connector 25">
+            <a:extLst>
+              <a:ext uri="{FF2B5EF4-FFF2-40B4-BE49-F238E27FC236}">
+                <a16:creationId xmlns:a16="http://schemas.microsoft.com/office/drawing/2014/main" id="{EBC8AEE3-6740-38F5-E24C-365736502DCD}"/>
+              </a:ext>
+            </a:extLst>
+          </p:cNvPr>
+          <p:cNvCxnSpPr>
+            <a:cxnSpLocks/>
+            <a:stCxn id="18" idx="1"/>
+          </p:cNvCxnSpPr>
+          <p:nvPr/>
+        </p:nvCxnSpPr>
+        <p:spPr>
+          <a:xfrm flipH="1" flipV="1">
+            <a:off x="1734207" y="1422692"/>
+            <a:ext cx="1462996" cy="864204"/>
+          </a:xfrm>
+          <a:prstGeom prst="straightConnector1">
+            <a:avLst/>
+          </a:prstGeom>
+          <a:ln w="38100">
+            <a:solidFill>
+              <a:srgbClr val="FF0000"/>
+            </a:solidFill>
+            <a:tailEnd type="oval" w="lg" len="lg"/>
+          </a:ln>
+          <a:effectLst/>
+        </p:spPr>
+        <p:style>
+          <a:lnRef idx="2">
+            <a:schemeClr val="accent1"/>
+          </a:lnRef>
+          <a:fillRef idx="0">
+            <a:schemeClr val="accent1"/>
+          </a:fillRef>
+          <a:effectRef idx="1">
+            <a:schemeClr val="accent1"/>
+          </a:effectRef>
+          <a:fontRef idx="minor">
+            <a:schemeClr val="tx1"/>
+          </a:fontRef>
+        </p:style>
+      </p:cxnSp>
     </p:spTree>
     <p:extLst>
       <p:ext uri="{BB962C8B-B14F-4D97-AF65-F5344CB8AC3E}">
-        <p14:creationId xmlns:p14="http://schemas.microsoft.com/office/powerpoint/2010/main" val="537491648"/>
+        <p14:creationId xmlns:p14="http://schemas.microsoft.com/office/powerpoint/2010/main" val="1007983689"/>
       </p:ext>
     </p:extLst>
   </p:cSld>

</xml_diff>